<commit_message>
Update Fig 1 coordinate figure with revised PowerPoint edits
Co-Authored-By: Claude Opus 4.8 (1M context) <noreply@anthropic.com>
</commit_message>
<xml_diff>
--- a/Figure1_coordinate.pptx
+++ b/Figure1_coordinate.pptx
@@ -3104,10 +3104,10 @@
         </p:nvGrpSpPr>
         <p:grpSpPr>
           <a:xfrm>
-            <a:off x="1939891" y="3267479"/>
-            <a:ext cx="2990088" cy="2606040"/>
-            <a:chOff x="393192" y="3474720"/>
-            <a:chExt cx="2990088" cy="2606040"/>
+            <a:off x="2236757" y="3342190"/>
+            <a:ext cx="2338649" cy="2456617"/>
+            <a:chOff x="690058" y="3549431"/>
+            <a:chExt cx="2338649" cy="2456617"/>
           </a:xfrm>
         </p:grpSpPr>
         <p:cxnSp>
@@ -3190,8 +3190,8 @@
           </p:nvSpPr>
           <p:spPr>
             <a:xfrm>
-              <a:off x="594360" y="3474720"/>
-              <a:ext cx="822960" cy="457200"/>
+              <a:off x="941720" y="3549431"/>
+              <a:ext cx="128240" cy="307777"/>
             </a:xfrm>
             <a:prstGeom prst="rect">
               <a:avLst/>
@@ -3206,7 +3206,7 @@
             <a:p>
               <a:pPr algn="ctr"/>
               <a:r>
-                <a:rPr sz="1700" i="1">
+                <a:rPr sz="2000" b="1" i="1">
                   <a:solidFill>
                     <a:srgbClr val="222222"/>
                   </a:solidFill>
@@ -3225,8 +3225,8 @@
           </p:nvSpPr>
           <p:spPr>
             <a:xfrm>
-              <a:off x="2560320" y="5440680"/>
-              <a:ext cx="822960" cy="457200"/>
+              <a:off x="2914893" y="5515391"/>
+              <a:ext cx="113814" cy="307777"/>
             </a:xfrm>
             <a:prstGeom prst="rect">
               <a:avLst/>
@@ -3241,7 +3241,7 @@
             <a:p>
               <a:pPr algn="ctr"/>
               <a:r>
-                <a:rPr sz="1700" i="1">
+                <a:rPr sz="2000" b="1" i="1">
                   <a:solidFill>
                     <a:srgbClr val="222222"/>
                   </a:solidFill>
@@ -3260,8 +3260,8 @@
           </p:nvSpPr>
           <p:spPr>
             <a:xfrm>
-              <a:off x="393192" y="5623560"/>
-              <a:ext cx="822960" cy="457200"/>
+              <a:off x="690058" y="5698271"/>
+              <a:ext cx="229230" cy="307777"/>
             </a:xfrm>
             <a:prstGeom prst="rect">
               <a:avLst/>
@@ -3276,7 +3276,7 @@
             <a:p>
               <a:pPr algn="ctr"/>
               <a:r>
-                <a:rPr sz="1700" i="1">
+                <a:rPr sz="2000" b="1" i="1">
                   <a:solidFill>
                     <a:srgbClr val="222222"/>
                   </a:solidFill>
@@ -3285,7 +3285,7 @@
                 <a:t>O</a:t>
               </a:r>
               <a:r>
-                <a:rPr sz="1400" i="1" baseline="-25000">
+                <a:rPr b="1" i="1" baseline="-25000">
                   <a:solidFill>
                     <a:srgbClr val="222222"/>
                   </a:solidFill>
@@ -3311,10 +3311,10 @@
         </p:nvGrpSpPr>
         <p:grpSpPr>
           <a:xfrm>
-            <a:off x="2687979" y="1524901"/>
-            <a:ext cx="3473298" cy="3520650"/>
-            <a:chOff x="2687979" y="1524901"/>
-            <a:chExt cx="3473298" cy="3520650"/>
+            <a:off x="3013699" y="1599612"/>
+            <a:ext cx="2807432" cy="3427162"/>
+            <a:chOff x="3013699" y="1599612"/>
+            <a:chExt cx="2807432" cy="3427162"/>
           </a:xfrm>
         </p:grpSpPr>
         <p:sp>
@@ -3401,7 +3401,7 @@
             <a:lstStyle/>
             <a:p>
               <a:pPr algn="ctr"/>
-              <a:endParaRPr/>
+              <a:endParaRPr sz="2400" b="1"/>
             </a:p>
           </p:txBody>
         </p:sp>
@@ -3480,7 +3480,7 @@
             <a:lstStyle/>
             <a:p>
               <a:pPr algn="ctr"/>
-              <a:endParaRPr/>
+              <a:endParaRPr sz="2400" b="1"/>
             </a:p>
           </p:txBody>
         </p:sp>
@@ -3551,7 +3551,7 @@
             <a:lstStyle/>
             <a:p>
               <a:pPr algn="ctr"/>
-              <a:endParaRPr/>
+              <a:endParaRPr sz="2400" b="1"/>
             </a:p>
           </p:txBody>
         </p:sp>
@@ -3618,7 +3618,7 @@
             <a:lstStyle/>
             <a:p>
               <a:pPr algn="ctr"/>
-              <a:endParaRPr/>
+              <a:endParaRPr sz="2400" b="1"/>
             </a:p>
           </p:txBody>
         </p:sp>
@@ -3682,7 +3682,7 @@
               <a:lstStyle/>
               <a:p>
                 <a:pPr algn="ctr"/>
-                <a:endParaRPr/>
+                <a:endParaRPr sz="2400" b="1"/>
               </a:p>
             </p:txBody>
           </p:sp>
@@ -3726,7 +3726,7 @@
               <a:lstStyle/>
               <a:p>
                 <a:pPr algn="ctr"/>
-                <a:endParaRPr/>
+                <a:endParaRPr sz="2400" b="1"/>
               </a:p>
             </p:txBody>
           </p:sp>
@@ -3770,7 +3770,7 @@
               <a:lstStyle/>
               <a:p>
                 <a:pPr algn="ctr"/>
-                <a:endParaRPr/>
+                <a:endParaRPr sz="2400" b="1"/>
               </a:p>
             </p:txBody>
           </p:sp>
@@ -3814,7 +3814,7 @@
               <a:lstStyle/>
               <a:p>
                 <a:pPr algn="ctr"/>
-                <a:endParaRPr/>
+                <a:endParaRPr sz="2400" b="1"/>
               </a:p>
             </p:txBody>
           </p:sp>
@@ -3865,8 +3865,8 @@
           </p:nvSpPr>
           <p:spPr>
             <a:xfrm>
-              <a:off x="2687979" y="4397804"/>
-              <a:ext cx="822960" cy="457200"/>
+              <a:off x="3013699" y="4472515"/>
+              <a:ext cx="171522" cy="307777"/>
             </a:xfrm>
             <a:prstGeom prst="rect">
               <a:avLst/>
@@ -3881,7 +3881,7 @@
             <a:p>
               <a:pPr algn="ctr"/>
               <a:r>
-                <a:rPr sz="1700" i="1">
+                <a:rPr sz="2000" b="1" i="1">
                   <a:solidFill>
                     <a:srgbClr val="C0392B"/>
                   </a:solidFill>
@@ -3936,8 +3936,8 @@
           </p:nvSpPr>
           <p:spPr>
             <a:xfrm>
-              <a:off x="3055997" y="4588351"/>
-              <a:ext cx="822960" cy="457200"/>
+              <a:off x="3401754" y="4663062"/>
+              <a:ext cx="131446" cy="307777"/>
             </a:xfrm>
             <a:prstGeom prst="rect">
               <a:avLst/>
@@ -3952,7 +3952,7 @@
             <a:p>
               <a:pPr algn="ctr"/>
               <a:r>
-                <a:rPr sz="1700" i="1">
+                <a:rPr sz="2000" b="1" i="1">
                   <a:solidFill>
                     <a:srgbClr val="222222"/>
                   </a:solidFill>
@@ -4003,7 +4003,7 @@
             <a:lstStyle/>
             <a:p>
               <a:pPr algn="ctr"/>
-              <a:endParaRPr/>
+              <a:endParaRPr sz="2400" b="1"/>
             </a:p>
           </p:txBody>
         </p:sp>
@@ -4015,8 +4015,8 @@
           </p:nvSpPr>
           <p:spPr>
             <a:xfrm>
-              <a:off x="3892375" y="3294192"/>
-              <a:ext cx="822960" cy="457200"/>
+              <a:off x="4616575" y="3324322"/>
+              <a:ext cx="262892" cy="307777"/>
             </a:xfrm>
             <a:prstGeom prst="rect">
               <a:avLst/>
@@ -4031,7 +4031,7 @@
             <a:p>
               <a:pPr algn="ctr"/>
               <a:r>
-                <a:rPr sz="1700" i="1" dirty="0">
+                <a:rPr sz="2000" b="1" i="1" dirty="0">
                   <a:solidFill>
                     <a:srgbClr val="222222"/>
                   </a:solidFill>
@@ -4040,7 +4040,7 @@
                 <a:t>O</a:t>
               </a:r>
               <a:r>
-                <a:rPr sz="1400" i="1" baseline="-25000" dirty="0">
+                <a:rPr b="1" i="1" baseline="-25000" dirty="0">
                   <a:solidFill>
                     <a:srgbClr val="222222"/>
                   </a:solidFill>
@@ -4131,8 +4131,8 @@
           </p:nvSpPr>
           <p:spPr>
             <a:xfrm>
-              <a:off x="5338317" y="1524901"/>
-              <a:ext cx="822960" cy="457200"/>
+              <a:off x="5678463" y="1599612"/>
+              <a:ext cx="142668" cy="307777"/>
             </a:xfrm>
             <a:prstGeom prst="rect">
               <a:avLst/>
@@ -4147,7 +4147,7 @@
             <a:p>
               <a:pPr algn="ctr"/>
               <a:r>
-                <a:rPr sz="1700" i="1">
+                <a:rPr sz="2000" b="1" i="1">
                   <a:solidFill>
                     <a:srgbClr val="222222"/>
                   </a:solidFill>
@@ -4166,8 +4166,8 @@
           </p:nvSpPr>
           <p:spPr>
             <a:xfrm>
-              <a:off x="5132706" y="4082319"/>
-              <a:ext cx="822960" cy="457200"/>
+              <a:off x="5487279" y="4157030"/>
+              <a:ext cx="113814" cy="307777"/>
             </a:xfrm>
             <a:prstGeom prst="rect">
               <a:avLst/>
@@ -4182,7 +4182,7 @@
             <a:p>
               <a:pPr algn="ctr"/>
               <a:r>
-                <a:rPr sz="1700" i="1">
+                <a:rPr sz="2000" b="1" i="1">
                   <a:solidFill>
                     <a:srgbClr val="222222"/>
                   </a:solidFill>
@@ -4291,7 +4291,7 @@
             <a:lstStyle/>
             <a:p>
               <a:pPr algn="ctr"/>
-              <a:endParaRPr/>
+              <a:endParaRPr sz="2400" b="1"/>
             </a:p>
           </p:txBody>
         </p:sp>
@@ -4303,8 +4303,8 @@
           </p:nvSpPr>
           <p:spPr>
             <a:xfrm>
-              <a:off x="3382615" y="2846369"/>
-              <a:ext cx="822960" cy="457200"/>
+              <a:off x="3744402" y="2921080"/>
+              <a:ext cx="99387" cy="307777"/>
             </a:xfrm>
             <a:prstGeom prst="rect">
               <a:avLst/>
@@ -4319,7 +4319,7 @@
             <a:p>
               <a:pPr algn="ctr"/>
               <a:r>
-                <a:rPr sz="1700" i="1">
+                <a:rPr sz="2000" b="1" i="1">
                   <a:solidFill>
                     <a:srgbClr val="222222"/>
                   </a:solidFill>
@@ -4374,8 +4374,8 @@
           </p:nvSpPr>
           <p:spPr>
             <a:xfrm>
-              <a:off x="3615830" y="3634143"/>
-              <a:ext cx="822960" cy="457200"/>
+              <a:off x="3962388" y="3708854"/>
+              <a:ext cx="129844" cy="307777"/>
             </a:xfrm>
             <a:prstGeom prst="rect">
               <a:avLst/>
@@ -4390,7 +4390,7 @@
             <a:p>
               <a:pPr algn="ctr"/>
               <a:r>
-                <a:rPr sz="1700" i="1">
+                <a:rPr sz="2000" b="1" i="1">
                   <a:solidFill>
                     <a:srgbClr val="2E7D32"/>
                   </a:solidFill>
@@ -4399,7 +4399,7 @@
                 <a:t>l</a:t>
               </a:r>
               <a:r>
-                <a:rPr sz="1400" i="1" baseline="-25000">
+                <a:rPr b="1" i="1" baseline="-25000">
                   <a:solidFill>
                     <a:srgbClr val="2E7D32"/>
                   </a:solidFill>
@@ -4450,7 +4450,7 @@
             <a:lstStyle/>
             <a:p>
               <a:pPr algn="ctr"/>
-              <a:endParaRPr/>
+              <a:endParaRPr sz="2400" b="1"/>
             </a:p>
           </p:txBody>
         </p:sp>
@@ -4462,8 +4462,8 @@
           </p:nvSpPr>
           <p:spPr>
             <a:xfrm>
-              <a:off x="5099915" y="2210121"/>
-              <a:ext cx="822960" cy="457200"/>
+              <a:off x="5433649" y="2284832"/>
+              <a:ext cx="155492" cy="307777"/>
             </a:xfrm>
             <a:prstGeom prst="rect">
               <a:avLst/>
@@ -4478,7 +4478,7 @@
             <a:p>
               <a:pPr algn="ctr"/>
               <a:r>
-                <a:rPr sz="1700" i="1">
+                <a:rPr sz="2000" b="1" i="1">
                   <a:solidFill>
                     <a:srgbClr val="C0392B"/>
                   </a:solidFill>
@@ -4487,7 +4487,7 @@
                 <a:t>l</a:t>
               </a:r>
               <a:r>
-                <a:rPr sz="1400" i="1" baseline="-25000">
+                <a:rPr b="1" i="1" baseline="-25000">
                   <a:solidFill>
                     <a:srgbClr val="C0392B"/>
                   </a:solidFill>
@@ -4542,8 +4542,8 @@
           </p:nvSpPr>
           <p:spPr>
             <a:xfrm>
-              <a:off x="4331705" y="2063661"/>
-              <a:ext cx="822960" cy="457200"/>
+              <a:off x="4657424" y="2138372"/>
+              <a:ext cx="171522" cy="307777"/>
             </a:xfrm>
             <a:prstGeom prst="rect">
               <a:avLst/>
@@ -4558,7 +4558,7 @@
             <a:p>
               <a:pPr algn="ctr"/>
               <a:r>
-                <a:rPr sz="1700" i="1">
+                <a:rPr sz="2000" b="1" i="1">
                   <a:solidFill>
                     <a:srgbClr val="222222"/>
                   </a:solidFill>
@@ -4690,7 +4690,7 @@
             <a:lstStyle/>
             <a:p>
               <a:pPr algn="ctr"/>
-              <a:endParaRPr/>
+              <a:endParaRPr sz="2400" b="1"/>
             </a:p>
           </p:txBody>
         </p:sp>

</xml_diff>

<commit_message>
Update Fig 1 figure and set includegraphics width to 0.6 linewidth
Co-Authored-By: Claude Opus 4.8 (1M context) <noreply@anthropic.com>
</commit_message>
<xml_diff>
--- a/Figure1_coordinate.pptx
+++ b/Figure1_coordinate.pptx
@@ -4374,7 +4374,7 @@
           </p:nvSpPr>
           <p:spPr>
             <a:xfrm>
-              <a:off x="3962388" y="3708854"/>
+              <a:off x="4004328" y="3708854"/>
               <a:ext cx="129844" cy="307777"/>
             </a:xfrm>
             <a:prstGeom prst="rect">
@@ -4390,7 +4390,7 @@
             <a:p>
               <a:pPr algn="ctr"/>
               <a:r>
-                <a:rPr sz="2000" b="1" i="1">
+                <a:rPr sz="2000" b="1" i="1" dirty="0" err="1">
                   <a:solidFill>
                     <a:srgbClr val="2E7D32"/>
                   </a:solidFill>
@@ -4399,7 +4399,7 @@
                 <a:t>l</a:t>
               </a:r>
               <a:r>
-                <a:rPr b="1" i="1" baseline="-25000">
+                <a:rPr b="1" i="1" baseline="-25000" dirty="0" err="1">
                   <a:solidFill>
                     <a:srgbClr val="2E7D32"/>
                   </a:solidFill>
@@ -4407,6 +4407,12 @@
                 </a:rPr>
                 <a:t>r</a:t>
               </a:r>
+              <a:endParaRPr b="1" i="1" baseline="-25000" dirty="0">
+                <a:solidFill>
+                  <a:srgbClr val="2E7D32"/>
+                </a:solidFill>
+                <a:latin typeface="Times New Roman"/>
+              </a:endParaRPr>
             </a:p>
           </p:txBody>
         </p:sp>

</xml_diff>